<commit_message>
Strengthen theory, replication framing, and declarations
</commit_message>
<xml_diff>
--- a/publication/presentation/bangladesh_climate_destination_choice_7_slide_presentation.pptx
+++ b/publication/presentation/bangladesh_climate_destination_choice_7_slide_presentation.pptx
@@ -2,19 +2,19 @@
 <file path=ppt/presentation.xml><?xml version="1.0" encoding="utf-8"?>
 <p:presentation xmlns:p="http://schemas.openxmlformats.org/presentationml/2006/main">
   <p:sldMasterIdLst>
-    <p:sldMasterId xmlns:r="http://schemas.openxmlformats.org/officeDocument/2006/relationships" id="2147483648" r:id="R8c5f88f2168149a9"/>
+    <p:sldMasterId xmlns:r="http://schemas.openxmlformats.org/officeDocument/2006/relationships" id="2147483648" r:id="R14a6ceb2e8484423"/>
   </p:sldMasterIdLst>
   <p:notesMasterIdLst>
-    <p:notesMasterId xmlns:r="http://schemas.openxmlformats.org/officeDocument/2006/relationships" r:id="R6a54cf5610c249c6"/>
+    <p:notesMasterId xmlns:r="http://schemas.openxmlformats.org/officeDocument/2006/relationships" r:id="Rf427b72b808243aa"/>
   </p:notesMasterIdLst>
   <p:sldIdLst>
-    <p:sldId xmlns:r="http://schemas.openxmlformats.org/officeDocument/2006/relationships" id="256" r:id="R1513c2cda9304199"/>
-    <p:sldId xmlns:r="http://schemas.openxmlformats.org/officeDocument/2006/relationships" id="257" r:id="R7a4a07051f6d4dfd"/>
-    <p:sldId xmlns:r="http://schemas.openxmlformats.org/officeDocument/2006/relationships" id="258" r:id="R992997e29d6b4019"/>
-    <p:sldId xmlns:r="http://schemas.openxmlformats.org/officeDocument/2006/relationships" id="259" r:id="R01dca206e6ef4f5f"/>
-    <p:sldId xmlns:r="http://schemas.openxmlformats.org/officeDocument/2006/relationships" id="260" r:id="Rebe4d19111cf46a9"/>
-    <p:sldId xmlns:r="http://schemas.openxmlformats.org/officeDocument/2006/relationships" id="261" r:id="Rbefa8aab4bc54a24"/>
-    <p:sldId xmlns:r="http://schemas.openxmlformats.org/officeDocument/2006/relationships" id="262" r:id="Rdb532df4af314360"/>
+    <p:sldId xmlns:r="http://schemas.openxmlformats.org/officeDocument/2006/relationships" id="256" r:id="Rdbedeb0f18fd4fa2"/>
+    <p:sldId xmlns:r="http://schemas.openxmlformats.org/officeDocument/2006/relationships" id="257" r:id="Rc2b7bc49916541a4"/>
+    <p:sldId xmlns:r="http://schemas.openxmlformats.org/officeDocument/2006/relationships" id="258" r:id="R12125c97e82f4b71"/>
+    <p:sldId xmlns:r="http://schemas.openxmlformats.org/officeDocument/2006/relationships" id="259" r:id="Rd4c8cb15be5d4640"/>
+    <p:sldId xmlns:r="http://schemas.openxmlformats.org/officeDocument/2006/relationships" id="260" r:id="R3d839f9db0e24483"/>
+    <p:sldId xmlns:r="http://schemas.openxmlformats.org/officeDocument/2006/relationships" id="261" r:id="R8558683ff43c48e7"/>
+    <p:sldId xmlns:r="http://schemas.openxmlformats.org/officeDocument/2006/relationships" id="262" r:id="R9d33963255224d1c"/>
   </p:sldIdLst>
   <p:sldSz cx="12192000" cy="6858000"/>
   <p:notesSz cx="6858000" cy="9144000"/>
@@ -638,7 +638,7 @@
           <a:lstStyle xmlns:a="http://schemas.openxmlformats.org/drawingml/2006/main"/>
           <a:p xmlns:a="http://schemas.openxmlformats.org/drawingml/2006/main">
             <a:r>
-              <a:t>The comparison is between a transparent distance-population baseline and a GIS-expanded conditional logit. Main estimates use grouped cross-validation by origin. The outcome is observed district choice conditional on moving, not whether a household moves.</a:t>
+              <a:t>The comparison is between a transparent distance-population baseline and a GIS-expanded conditional logit. Main estimates group validation folds by household. Separate origin-held-out and later-wave tests ask whether the destination utility travels. The outcome is observed district choice conditional on moving, not whether a household moves.</a:t>
             </a:r>
           </a:p>
           <a:p xmlns:a="http://schemas.openxmlformats.org/drawingml/2006/main">
@@ -738,7 +738,7 @@
           <a:lstStyle xmlns:a="http://schemas.openxmlformats.org/drawingml/2006/main"/>
           <a:p xmlns:a="http://schemas.openxmlformats.org/drawingml/2006/main">
             <a:r>
-              <a:t>Lead with replication. The main BEMP and BIHS erosion-linked estimates are close: 10.8 and 9.8 percentage points. Confidence intervals are shown in the figure. The all-moves and baseline-migrant samples widen origin coverage and remain positive.</a:t>
+              <a:t>Lead with the independent BIHS transport result. The sample covers all 64 origin districts. GIS retains a 0.101 log-loss gain when each test origin is removed from training and a 0.094 gain when a 2015 model predicts 2018–19 migrants. These are not climate-labeled migrants; they test geographic and temporal portability of the destination specification.</a:t>
             </a:r>
           </a:p>
           <a:p xmlns:a="http://schemas.openxmlformats.org/drawingml/2006/main">
@@ -753,12 +753,7 @@
           </a:p>
           <a:p xmlns:a="http://schemas.openxmlformats.org/drawingml/2006/main">
             <a:r>
-              <a:t>Local frozen summary: outputs/tables/cross_dataset_replication_summary.csv</a:t>
-            </a:r>
-          </a:p>
-          <a:p xmlns:a="http://schemas.openxmlformats.org/drawingml/2006/main">
-            <a:r>
-              <a:t>BEMP public-use data: https://doi.org/10.5281/zenodo.18229498</a:t>
+              <a:t>Local validation output: outputs/tables/bihs_replication_validation.csv</a:t>
             </a:r>
           </a:p>
           <a:p xmlns:a="http://schemas.openxmlformats.org/drawingml/2006/main">
@@ -838,7 +833,7 @@
           <a:lstStyle xmlns:a="http://schemas.openxmlformats.org/drawingml/2006/main"/>
           <a:p xmlns:a="http://schemas.openxmlformats.org/drawingml/2006/main">
             <a:r>
-              <a:t>The leave-one-origin-out check separates two questions. Destination ranking retains positive gains in the wide BIHS sample. Migration incidence is origin-specific and should not be presented as a nationally portable forecast.</a:t>
+              <a:t>The climate-specific samples use the same destination outcome and fixed feature set. BIHS independently identifies erosion-related land loss as the move reason; BEMP provides the stronger sequence from a recorded shock to a later relocation. Prior BEMP research asks whether shocks change migration likelihood, type, or distance. This project conditions on a move and predicts its district.</a:t>
             </a:r>
           </a:p>
           <a:p xmlns:a="http://schemas.openxmlformats.org/drawingml/2006/main">
@@ -853,12 +848,22 @@
           </a:p>
           <a:p xmlns:a="http://schemas.openxmlformats.org/drawingml/2006/main">
             <a:r>
-              <a:t>Local validation output: outputs/tables/bihs_replication_validation.csv</a:t>
-            </a:r>
-          </a:p>
-          <a:p xmlns:a="http://schemas.openxmlformats.org/drawingml/2006/main">
-            <a:r>
-              <a:t>Local figure: outputs/figures/validation_transportability_comparison.png</a:t>
+              <a:t>Local frozen summary: outputs/tables/cross_dataset_replication_summary.csv</a:t>
+            </a:r>
+          </a:p>
+          <a:p xmlns:a="http://schemas.openxmlformats.org/drawingml/2006/main">
+            <a:r>
+              <a:t>BEMP public-use data: https://doi.org/10.5281/zenodo.18229498</a:t>
+            </a:r>
+          </a:p>
+          <a:p xmlns:a="http://schemas.openxmlformats.org/drawingml/2006/main">
+            <a:r>
+              <a:t>BIHS public-use data: https://doi.org/10.7910/DVN/OR6MHT</a:t>
+            </a:r>
+          </a:p>
+          <a:p xmlns:a="http://schemas.openxmlformats.org/drawingml/2006/main">
+            <a:r>
+              <a:t>Existing BEMP incidence paper: https://doi.org/10.1007/s11111-025-00478-7</a:t>
             </a:r>
           </a:p>
           <a:p xmlns:a="http://schemas.openxmlformats.org/drawingml/2006/main">
@@ -1121,7 +1126,7 @@
   </p:cSld>
   <p:clrMap bg1="lt1" tx1="dk1" bg2="lt2" tx2="dk2" accent1="accent1" accent2="accent2" accent3="accent3" accent4="accent4" accent5="accent5" accent6="accent6" hlink="hlink" folHlink="folHlink"/>
   <p:sldLayoutIdLst>
-    <p:sldLayoutId xmlns:r="http://schemas.openxmlformats.org/officeDocument/2006/relationships" id="2147483649" r:id="R55f02bf6fdb642b7"/>
+    <p:sldLayoutId xmlns:r="http://schemas.openxmlformats.org/officeDocument/2006/relationships" id="2147483649" r:id="R256cd7d2143a41f7"/>
   </p:sldLayoutIdLst>
   <p:txStyles>
     <p:titleStyle>
@@ -1672,7 +1677,7 @@
           <p:cNvPr id="8" name="cover-accent">
             <a:extLst xmlns:a="http://schemas.openxmlformats.org/drawingml/2006/main">
               <a:ext uri="{FF2B5EF4-FFF2-40B4-BE49-F238E27FC236}">
-                <a16:creationId xmlns:a16="http://schemas.microsoft.com/office/drawing/2014/main" id="{CEC3341C-E5BE-4558-B9B2-D63DAEB5BC97}"/>
+                <a16:creationId xmlns:a16="http://schemas.microsoft.com/office/drawing/2014/main" id="{703EA7A1-ECF1-4CEB-8B78-5D9F4AC680E0}"/>
               </a:ext>
             </a:extLst>
           </p:cNvPr>
@@ -1703,7 +1708,7 @@
           <p:cNvPr id="2" name="cover-kicker">
             <a:extLst xmlns:a="http://schemas.openxmlformats.org/drawingml/2006/main">
               <a:ext uri="{FF2B5EF4-FFF2-40B4-BE49-F238E27FC236}">
-                <a16:creationId xmlns:a16="http://schemas.microsoft.com/office/drawing/2014/main" id="{E6218F4E-DF00-4724-9E98-20A371A0896E}"/>
+                <a16:creationId xmlns:a16="http://schemas.microsoft.com/office/drawing/2014/main" id="{9FBAC242-8897-47CA-B3D9-35F178BA3F76}"/>
               </a:ext>
             </a:extLst>
           </p:cNvPr>
@@ -1753,7 +1758,7 @@
           <p:cNvPr id="3" name="cover-title">
             <a:extLst xmlns:a="http://schemas.openxmlformats.org/drawingml/2006/main">
               <a:ext uri="{FF2B5EF4-FFF2-40B4-BE49-F238E27FC236}">
-                <a16:creationId xmlns:a16="http://schemas.microsoft.com/office/drawing/2014/main" id="{92F5C707-AAA7-49D4-AEED-46B789EB3A08}"/>
+                <a16:creationId xmlns:a16="http://schemas.microsoft.com/office/drawing/2014/main" id="{05F69003-5DFB-417C-B891-41313D747B96}"/>
               </a:ext>
             </a:extLst>
           </p:cNvPr>
@@ -1803,7 +1808,7 @@
           <p:cNvPr id="4" name="cover-subtitle">
             <a:extLst xmlns:a="http://schemas.openxmlformats.org/drawingml/2006/main">
               <a:ext uri="{FF2B5EF4-FFF2-40B4-BE49-F238E27FC236}">
-                <a16:creationId xmlns:a16="http://schemas.microsoft.com/office/drawing/2014/main" id="{5FA952E7-1209-471F-9B0B-8C810B52B917}"/>
+                <a16:creationId xmlns:a16="http://schemas.microsoft.com/office/drawing/2014/main" id="{B8E54F52-99CE-4922-A0D6-BCAA4EBE7BB3}"/>
               </a:ext>
             </a:extLst>
           </p:cNvPr>
@@ -1853,7 +1858,7 @@
           <p:cNvPr id="5" name="cover-author">
             <a:extLst xmlns:a="http://schemas.openxmlformats.org/drawingml/2006/main">
               <a:ext uri="{FF2B5EF4-FFF2-40B4-BE49-F238E27FC236}">
-                <a16:creationId xmlns:a16="http://schemas.microsoft.com/office/drawing/2014/main" id="{D8989E18-EDF8-4BAE-9A63-D6B500BF828E}"/>
+                <a16:creationId xmlns:a16="http://schemas.microsoft.com/office/drawing/2014/main" id="{A39959BB-FF73-4ED6-8ACB-6EECD2E028D4}"/>
               </a:ext>
             </a:extLst>
           </p:cNvPr>
@@ -1893,7 +1898,7 @@
                   <a:srgbClr val="111827"/>
                 </a:solidFill>
               </a:rPr>
-              <a:t>Shail Belani  •  Northwestern University</a:t>
+              <a:t>Shail Belani  •  Undergraduate Researcher</a:t>
             </a:r>
           </a:p>
           <a:p xmlns:a="http://schemas.openxmlformats.org/drawingml/2006/main">
@@ -1910,7 +1915,7 @@
                   <a:srgbClr val="111827"/>
                 </a:solidFill>
               </a:rPr>
-              <a:t>Global Poverty Research Lab undergraduate researcher</a:t>
+              <a:t>Northwestern University</a:t>
             </a:r>
           </a:p>
         </p:txBody>
@@ -1924,7 +1929,7 @@
           <p:nvPr/>
         </p:nvPicPr>
         <p:blipFill>
-          <a:blip xmlns:r="http://schemas.openxmlformats.org/officeDocument/2006/relationships" xmlns:a="http://schemas.openxmlformats.org/drawingml/2006/main" r:embed="Re715aec2d59d4c16"/>
+          <a:blip xmlns:r="http://schemas.openxmlformats.org/officeDocument/2006/relationships" xmlns:a="http://schemas.openxmlformats.org/drawingml/2006/main" r:embed="Re835b864e3cd4fd2"/>
           <a:stretch xmlns:a="http://schemas.openxmlformats.org/drawingml/2006/main"/>
         </p:blipFill>
         <p:spPr>
@@ -1942,7 +1947,7 @@
           <p:cNvPr id="7" name="cover-number">
             <a:extLst xmlns:a="http://schemas.openxmlformats.org/drawingml/2006/main">
               <a:ext uri="{FF2B5EF4-FFF2-40B4-BE49-F238E27FC236}">
-                <a16:creationId xmlns:a16="http://schemas.microsoft.com/office/drawing/2014/main" id="{F7B2F269-698C-4AAA-815C-B7206B90FC56}"/>
+                <a16:creationId xmlns:a16="http://schemas.microsoft.com/office/drawing/2014/main" id="{E2BE88E8-66DC-4682-9A00-4201893E7B88}"/>
               </a:ext>
             </a:extLst>
           </p:cNvPr>
@@ -1990,7 +1995,7 @@
     </p:spTree>
     <p:extLst>
       <p:ext uri="{BB962C8B-B14F-4D97-AF65-F5344CB8AC3E}">
-        <p14:creationId xmlns:p14="http://schemas.microsoft.com/office/powerpoint/2010/main" val="524168392"/>
+        <p14:creationId xmlns:p14="http://schemas.microsoft.com/office/powerpoint/2010/main" val="806335694"/>
       </p:ext>
     </p:extLst>
   </p:cSld>
@@ -2021,7 +2026,7 @@
           <p:cNvPr id="17" name="kicker-2">
             <a:extLst xmlns:a="http://schemas.openxmlformats.org/drawingml/2006/main">
               <a:ext uri="{FF2B5EF4-FFF2-40B4-BE49-F238E27FC236}">
-                <a16:creationId xmlns:a16="http://schemas.microsoft.com/office/drawing/2014/main" id="{382F6C55-C269-4D01-953F-5182E9888A2C}"/>
+                <a16:creationId xmlns:a16="http://schemas.microsoft.com/office/drawing/2014/main" id="{54F7751C-3B8F-4BA6-B4DD-3BC05354CC5A}"/>
               </a:ext>
             </a:extLst>
           </p:cNvPr>
@@ -2071,7 +2076,7 @@
           <p:cNvPr id="2" name="title-2">
             <a:extLst xmlns:a="http://schemas.openxmlformats.org/drawingml/2006/main">
               <a:ext uri="{FF2B5EF4-FFF2-40B4-BE49-F238E27FC236}">
-                <a16:creationId xmlns:a16="http://schemas.microsoft.com/office/drawing/2014/main" id="{CF38C814-6940-47D1-A167-284F564897AF}"/>
+                <a16:creationId xmlns:a16="http://schemas.microsoft.com/office/drawing/2014/main" id="{C38CBEA1-0DBE-4AC0-AF9A-D60D7A83D861}"/>
               </a:ext>
             </a:extLst>
           </p:cNvPr>
@@ -2121,7 +2126,7 @@
           <p:cNvPr id="3" name="header-rule-2">
             <a:extLst xmlns:a="http://schemas.openxmlformats.org/drawingml/2006/main">
               <a:ext uri="{FF2B5EF4-FFF2-40B4-BE49-F238E27FC236}">
-                <a16:creationId xmlns:a16="http://schemas.microsoft.com/office/drawing/2014/main" id="{8B3A4663-A194-4047-B10A-F2B4CF6F1F0F}"/>
+                <a16:creationId xmlns:a16="http://schemas.microsoft.com/office/drawing/2014/main" id="{79E78AA4-5743-40B1-BFD7-EE9047D8CA6A}"/>
               </a:ext>
             </a:extLst>
           </p:cNvPr>
@@ -2152,7 +2157,7 @@
           <p:cNvPr id="4" name="number-2">
             <a:extLst xmlns:a="http://schemas.openxmlformats.org/drawingml/2006/main">
               <a:ext uri="{FF2B5EF4-FFF2-40B4-BE49-F238E27FC236}">
-                <a16:creationId xmlns:a16="http://schemas.microsoft.com/office/drawing/2014/main" id="{66E843C0-8A29-4792-A255-085957125739}"/>
+                <a16:creationId xmlns:a16="http://schemas.microsoft.com/office/drawing/2014/main" id="{AE0E8F55-14F8-4B57-A5D7-AFC4BE5BC52F}"/>
               </a:ext>
             </a:extLst>
           </p:cNvPr>
@@ -2202,7 +2207,7 @@
           <p:cNvPr id="5" name="timeline">
             <a:extLst xmlns:a="http://schemas.openxmlformats.org/drawingml/2006/main">
               <a:ext uri="{FF2B5EF4-FFF2-40B4-BE49-F238E27FC236}">
-                <a16:creationId xmlns:a16="http://schemas.microsoft.com/office/drawing/2014/main" id="{978FB654-ED39-4963-A0BA-7215270F9886}"/>
+                <a16:creationId xmlns:a16="http://schemas.microsoft.com/office/drawing/2014/main" id="{1B1E2028-AD9A-4677-B123-8C3505BBF43E}"/>
               </a:ext>
             </a:extLst>
           </p:cNvPr>
@@ -2233,7 +2238,7 @@
           <p:cNvPr id="6" name="dot-0">
             <a:extLst xmlns:a="http://schemas.openxmlformats.org/drawingml/2006/main">
               <a:ext uri="{FF2B5EF4-FFF2-40B4-BE49-F238E27FC236}">
-                <a16:creationId xmlns:a16="http://schemas.microsoft.com/office/drawing/2014/main" id="{3518ED4F-ABDC-423B-88F7-40C290E4AE4D}"/>
+                <a16:creationId xmlns:a16="http://schemas.microsoft.com/office/drawing/2014/main" id="{763D8A9C-7055-46C3-B1AD-50559CF4BCD2}"/>
               </a:ext>
             </a:extLst>
           </p:cNvPr>
@@ -2264,7 +2269,7 @@
           <p:cNvPr id="7" name="step-title-0">
             <a:extLst xmlns:a="http://schemas.openxmlformats.org/drawingml/2006/main">
               <a:ext uri="{FF2B5EF4-FFF2-40B4-BE49-F238E27FC236}">
-                <a16:creationId xmlns:a16="http://schemas.microsoft.com/office/drawing/2014/main" id="{A2A83610-8029-447A-934E-FA749D7E45C8}"/>
+                <a16:creationId xmlns:a16="http://schemas.microsoft.com/office/drawing/2014/main" id="{FD54883A-C8C6-4EBE-8326-F4D32DBE6BE3}"/>
               </a:ext>
             </a:extLst>
           </p:cNvPr>
@@ -2314,7 +2319,7 @@
           <p:cNvPr id="8" name="step-body-0">
             <a:extLst xmlns:a="http://schemas.openxmlformats.org/drawingml/2006/main">
               <a:ext uri="{FF2B5EF4-FFF2-40B4-BE49-F238E27FC236}">
-                <a16:creationId xmlns:a16="http://schemas.microsoft.com/office/drawing/2014/main" id="{6A822A29-FABA-4092-9CF9-1FBB77FED988}"/>
+                <a16:creationId xmlns:a16="http://schemas.microsoft.com/office/drawing/2014/main" id="{EF730496-D51B-4477-B5AD-B72426F1E1FA}"/>
               </a:ext>
             </a:extLst>
           </p:cNvPr>
@@ -2364,7 +2369,7 @@
           <p:cNvPr id="9" name="dot-1">
             <a:extLst xmlns:a="http://schemas.openxmlformats.org/drawingml/2006/main">
               <a:ext uri="{FF2B5EF4-FFF2-40B4-BE49-F238E27FC236}">
-                <a16:creationId xmlns:a16="http://schemas.microsoft.com/office/drawing/2014/main" id="{AE5FAE04-CFB3-458E-8961-37C23A5D08B8}"/>
+                <a16:creationId xmlns:a16="http://schemas.microsoft.com/office/drawing/2014/main" id="{CFB91331-2276-4F9D-80D9-AF4E9351BB6D}"/>
               </a:ext>
             </a:extLst>
           </p:cNvPr>
@@ -2395,7 +2400,7 @@
           <p:cNvPr id="10" name="step-title-1">
             <a:extLst xmlns:a="http://schemas.openxmlformats.org/drawingml/2006/main">
               <a:ext uri="{FF2B5EF4-FFF2-40B4-BE49-F238E27FC236}">
-                <a16:creationId xmlns:a16="http://schemas.microsoft.com/office/drawing/2014/main" id="{983D8748-056A-47B7-9DD2-2DEC8C451510}"/>
+                <a16:creationId xmlns:a16="http://schemas.microsoft.com/office/drawing/2014/main" id="{589CD337-E0E6-47AD-A543-FCF0E706D1DB}"/>
               </a:ext>
             </a:extLst>
           </p:cNvPr>
@@ -2445,7 +2450,7 @@
           <p:cNvPr id="11" name="step-body-1">
             <a:extLst xmlns:a="http://schemas.openxmlformats.org/drawingml/2006/main">
               <a:ext uri="{FF2B5EF4-FFF2-40B4-BE49-F238E27FC236}">
-                <a16:creationId xmlns:a16="http://schemas.microsoft.com/office/drawing/2014/main" id="{6572B4E6-4029-412D-A7E5-5B5E73B851C7}"/>
+                <a16:creationId xmlns:a16="http://schemas.microsoft.com/office/drawing/2014/main" id="{5E758D2F-EDBC-4245-92A7-F71914DD48EC}"/>
               </a:ext>
             </a:extLst>
           </p:cNvPr>
@@ -2495,7 +2500,7 @@
           <p:cNvPr id="12" name="dot-2">
             <a:extLst xmlns:a="http://schemas.openxmlformats.org/drawingml/2006/main">
               <a:ext uri="{FF2B5EF4-FFF2-40B4-BE49-F238E27FC236}">
-                <a16:creationId xmlns:a16="http://schemas.microsoft.com/office/drawing/2014/main" id="{E7E29F4D-DB46-4313-BBF2-54DFB201BC70}"/>
+                <a16:creationId xmlns:a16="http://schemas.microsoft.com/office/drawing/2014/main" id="{AF622039-FEE2-41D2-ADE0-BBDB18ED4DB6}"/>
               </a:ext>
             </a:extLst>
           </p:cNvPr>
@@ -2526,7 +2531,7 @@
           <p:cNvPr id="13" name="step-title-2">
             <a:extLst xmlns:a="http://schemas.openxmlformats.org/drawingml/2006/main">
               <a:ext uri="{FF2B5EF4-FFF2-40B4-BE49-F238E27FC236}">
-                <a16:creationId xmlns:a16="http://schemas.microsoft.com/office/drawing/2014/main" id="{D0098510-FBDC-43EB-AB81-1B2BFFB3D1DB}"/>
+                <a16:creationId xmlns:a16="http://schemas.microsoft.com/office/drawing/2014/main" id="{87E6F279-1EED-475A-AE0E-A5AC9F99D033}"/>
               </a:ext>
             </a:extLst>
           </p:cNvPr>
@@ -2576,7 +2581,7 @@
           <p:cNvPr id="14" name="step-body-2">
             <a:extLst xmlns:a="http://schemas.openxmlformats.org/drawingml/2006/main">
               <a:ext uri="{FF2B5EF4-FFF2-40B4-BE49-F238E27FC236}">
-                <a16:creationId xmlns:a16="http://schemas.microsoft.com/office/drawing/2014/main" id="{F90F2958-B24F-4AF1-B088-C1233320E9CF}"/>
+                <a16:creationId xmlns:a16="http://schemas.microsoft.com/office/drawing/2014/main" id="{134B9F49-E6AB-4786-AD70-4F011F136875}"/>
               </a:ext>
             </a:extLst>
           </p:cNvPr>
@@ -2626,7 +2631,7 @@
           <p:cNvPr id="15" name="prob-strip">
             <a:extLst xmlns:a="http://schemas.openxmlformats.org/drawingml/2006/main">
               <a:ext uri="{FF2B5EF4-FFF2-40B4-BE49-F238E27FC236}">
-                <a16:creationId xmlns:a16="http://schemas.microsoft.com/office/drawing/2014/main" id="{C0B06E70-D2A7-4DB8-AC53-468E42781DD8}"/>
+                <a16:creationId xmlns:a16="http://schemas.microsoft.com/office/drawing/2014/main" id="{FE64D75B-D539-421E-825A-44B2E3B13E5F}"/>
               </a:ext>
             </a:extLst>
           </p:cNvPr>
@@ -2657,7 +2662,7 @@
           <p:cNvPr id="16" name="probability">
             <a:extLst xmlns:a="http://schemas.openxmlformats.org/drawingml/2006/main">
               <a:ext uri="{FF2B5EF4-FFF2-40B4-BE49-F238E27FC236}">
-                <a16:creationId xmlns:a16="http://schemas.microsoft.com/office/drawing/2014/main" id="{5D80C5AB-E366-4D74-B8CA-137A1DD1DC38}"/>
+                <a16:creationId xmlns:a16="http://schemas.microsoft.com/office/drawing/2014/main" id="{15541E0D-384C-4432-BE63-43C4AF9CC7F8}"/>
               </a:ext>
             </a:extLst>
           </p:cNvPr>
@@ -2705,7 +2710,7 @@
     </p:spTree>
     <p:extLst>
       <p:ext uri="{BB962C8B-B14F-4D97-AF65-F5344CB8AC3E}">
-        <p14:creationId xmlns:p14="http://schemas.microsoft.com/office/powerpoint/2010/main" val="1451156172"/>
+        <p14:creationId xmlns:p14="http://schemas.microsoft.com/office/powerpoint/2010/main" val="1282755017"/>
       </p:ext>
     </p:extLst>
   </p:cSld>
@@ -2736,7 +2741,7 @@
           <p:cNvPr id="18" name="kicker-3">
             <a:extLst xmlns:a="http://schemas.openxmlformats.org/drawingml/2006/main">
               <a:ext uri="{FF2B5EF4-FFF2-40B4-BE49-F238E27FC236}">
-                <a16:creationId xmlns:a16="http://schemas.microsoft.com/office/drawing/2014/main" id="{8C9D2E34-7E9D-4826-BA01-ACE6449E31EF}"/>
+                <a16:creationId xmlns:a16="http://schemas.microsoft.com/office/drawing/2014/main" id="{DACED9B2-C28D-4FA8-9E79-54C9B03BCC5C}"/>
               </a:ext>
             </a:extLst>
           </p:cNvPr>
@@ -2786,7 +2791,7 @@
           <p:cNvPr id="2" name="title-3">
             <a:extLst xmlns:a="http://schemas.openxmlformats.org/drawingml/2006/main">
               <a:ext uri="{FF2B5EF4-FFF2-40B4-BE49-F238E27FC236}">
-                <a16:creationId xmlns:a16="http://schemas.microsoft.com/office/drawing/2014/main" id="{1C3ECC4C-20A6-4D51-A105-3C49F9800994}"/>
+                <a16:creationId xmlns:a16="http://schemas.microsoft.com/office/drawing/2014/main" id="{15628592-A209-4D4F-8C7B-D25439902D86}"/>
               </a:ext>
             </a:extLst>
           </p:cNvPr>
@@ -2836,7 +2841,7 @@
           <p:cNvPr id="3" name="header-rule-3">
             <a:extLst xmlns:a="http://schemas.openxmlformats.org/drawingml/2006/main">
               <a:ext uri="{FF2B5EF4-FFF2-40B4-BE49-F238E27FC236}">
-                <a16:creationId xmlns:a16="http://schemas.microsoft.com/office/drawing/2014/main" id="{457CF544-C016-468C-A7DB-EB8E98BDD21D}"/>
+                <a16:creationId xmlns:a16="http://schemas.microsoft.com/office/drawing/2014/main" id="{A2554F0E-F2D8-418E-AB17-45407426DDBC}"/>
               </a:ext>
             </a:extLst>
           </p:cNvPr>
@@ -2867,7 +2872,7 @@
           <p:cNvPr id="4" name="number-3">
             <a:extLst xmlns:a="http://schemas.openxmlformats.org/drawingml/2006/main">
               <a:ext uri="{FF2B5EF4-FFF2-40B4-BE49-F238E27FC236}">
-                <a16:creationId xmlns:a16="http://schemas.microsoft.com/office/drawing/2014/main" id="{7C46E674-0A8F-4B0D-A861-CC842C87F43B}"/>
+                <a16:creationId xmlns:a16="http://schemas.microsoft.com/office/drawing/2014/main" id="{D9B05C6D-2613-4FB8-B677-BDE61DDCC82B}"/>
               </a:ext>
             </a:extLst>
           </p:cNvPr>
@@ -2917,7 +2922,7 @@
           <p:cNvPr id="5" name="method-panel-0">
             <a:extLst xmlns:a="http://schemas.openxmlformats.org/drawingml/2006/main">
               <a:ext uri="{FF2B5EF4-FFF2-40B4-BE49-F238E27FC236}">
-                <a16:creationId xmlns:a16="http://schemas.microsoft.com/office/drawing/2014/main" id="{51E9BA8D-676D-4DDF-85A5-C936A0FC9BBA}"/>
+                <a16:creationId xmlns:a16="http://schemas.microsoft.com/office/drawing/2014/main" id="{81827D7F-FC6A-4E7A-BE21-BD4D58153265}"/>
               </a:ext>
             </a:extLst>
           </p:cNvPr>
@@ -2948,7 +2953,7 @@
           <p:cNvPr id="6" name="method-accent-0">
             <a:extLst xmlns:a="http://schemas.openxmlformats.org/drawingml/2006/main">
               <a:ext uri="{FF2B5EF4-FFF2-40B4-BE49-F238E27FC236}">
-                <a16:creationId xmlns:a16="http://schemas.microsoft.com/office/drawing/2014/main" id="{21A2486C-C5FC-4552-B9DA-07F049BFEDE0}"/>
+                <a16:creationId xmlns:a16="http://schemas.microsoft.com/office/drawing/2014/main" id="{A25DE05B-AF6F-4357-B580-DF6361D04B89}"/>
               </a:ext>
             </a:extLst>
           </p:cNvPr>
@@ -2979,7 +2984,7 @@
           <p:cNvPr id="7" name="method-label-0">
             <a:extLst xmlns:a="http://schemas.openxmlformats.org/drawingml/2006/main">
               <a:ext uri="{FF2B5EF4-FFF2-40B4-BE49-F238E27FC236}">
-                <a16:creationId xmlns:a16="http://schemas.microsoft.com/office/drawing/2014/main" id="{6EC49C34-EE84-4ACE-A7DA-6C364E77C8CE}"/>
+                <a16:creationId xmlns:a16="http://schemas.microsoft.com/office/drawing/2014/main" id="{CABC2B9C-2C10-4726-BAE7-95B7233EA49E}"/>
               </a:ext>
             </a:extLst>
           </p:cNvPr>
@@ -3029,7 +3034,7 @@
           <p:cNvPr id="8" name="method-copy-0">
             <a:extLst xmlns:a="http://schemas.openxmlformats.org/drawingml/2006/main">
               <a:ext uri="{FF2B5EF4-FFF2-40B4-BE49-F238E27FC236}">
-                <a16:creationId xmlns:a16="http://schemas.microsoft.com/office/drawing/2014/main" id="{45CCBEF0-28D5-4144-8096-B23E4DD15B76}"/>
+                <a16:creationId xmlns:a16="http://schemas.microsoft.com/office/drawing/2014/main" id="{7543B6CD-7C8E-4932-96F4-46D7D543DE41}"/>
               </a:ext>
             </a:extLst>
           </p:cNvPr>
@@ -3079,7 +3084,7 @@
           <p:cNvPr id="9" name="method-panel-1">
             <a:extLst xmlns:a="http://schemas.openxmlformats.org/drawingml/2006/main">
               <a:ext uri="{FF2B5EF4-FFF2-40B4-BE49-F238E27FC236}">
-                <a16:creationId xmlns:a16="http://schemas.microsoft.com/office/drawing/2014/main" id="{99DDD9B6-4EE5-4CF4-B12E-9E57D621F993}"/>
+                <a16:creationId xmlns:a16="http://schemas.microsoft.com/office/drawing/2014/main" id="{F3DBFFA3-85E8-4AED-A4D1-BD9A51D874BC}"/>
               </a:ext>
             </a:extLst>
           </p:cNvPr>
@@ -3110,7 +3115,7 @@
           <p:cNvPr id="10" name="method-accent-1">
             <a:extLst xmlns:a="http://schemas.openxmlformats.org/drawingml/2006/main">
               <a:ext uri="{FF2B5EF4-FFF2-40B4-BE49-F238E27FC236}">
-                <a16:creationId xmlns:a16="http://schemas.microsoft.com/office/drawing/2014/main" id="{F1FC4C2F-4D6F-4F33-8809-77D768CAE816}"/>
+                <a16:creationId xmlns:a16="http://schemas.microsoft.com/office/drawing/2014/main" id="{9E6195D2-D86D-486A-BC31-84ED25C217C7}"/>
               </a:ext>
             </a:extLst>
           </p:cNvPr>
@@ -3141,7 +3146,7 @@
           <p:cNvPr id="11" name="method-label-1">
             <a:extLst xmlns:a="http://schemas.openxmlformats.org/drawingml/2006/main">
               <a:ext uri="{FF2B5EF4-FFF2-40B4-BE49-F238E27FC236}">
-                <a16:creationId xmlns:a16="http://schemas.microsoft.com/office/drawing/2014/main" id="{318E23CA-0A05-47F4-89FC-EC482CA98D1B}"/>
+                <a16:creationId xmlns:a16="http://schemas.microsoft.com/office/drawing/2014/main" id="{86B7AAE4-C596-4DBA-A1EA-D4358277B95A}"/>
               </a:ext>
             </a:extLst>
           </p:cNvPr>
@@ -3191,7 +3196,7 @@
           <p:cNvPr id="12" name="method-copy-1">
             <a:extLst xmlns:a="http://schemas.openxmlformats.org/drawingml/2006/main">
               <a:ext uri="{FF2B5EF4-FFF2-40B4-BE49-F238E27FC236}">
-                <a16:creationId xmlns:a16="http://schemas.microsoft.com/office/drawing/2014/main" id="{7A325E3E-A4CB-4CB8-B26F-6CADF868598A}"/>
+                <a16:creationId xmlns:a16="http://schemas.microsoft.com/office/drawing/2014/main" id="{701B90FE-26A0-4842-893D-14197D0BD7C9}"/>
               </a:ext>
             </a:extLst>
           </p:cNvPr>
@@ -3241,7 +3246,7 @@
           <p:cNvPr id="13" name="method-panel-2">
             <a:extLst xmlns:a="http://schemas.openxmlformats.org/drawingml/2006/main">
               <a:ext uri="{FF2B5EF4-FFF2-40B4-BE49-F238E27FC236}">
-                <a16:creationId xmlns:a16="http://schemas.microsoft.com/office/drawing/2014/main" id="{B77A94E1-D672-4017-B0CC-1770BAEBF9AA}"/>
+                <a16:creationId xmlns:a16="http://schemas.microsoft.com/office/drawing/2014/main" id="{D2252161-D410-4493-91AE-E99D4A7D22A9}"/>
               </a:ext>
             </a:extLst>
           </p:cNvPr>
@@ -3272,7 +3277,7 @@
           <p:cNvPr id="14" name="method-accent-2">
             <a:extLst xmlns:a="http://schemas.openxmlformats.org/drawingml/2006/main">
               <a:ext uri="{FF2B5EF4-FFF2-40B4-BE49-F238E27FC236}">
-                <a16:creationId xmlns:a16="http://schemas.microsoft.com/office/drawing/2014/main" id="{75406AA4-E681-44FA-BEB8-AA95603193A8}"/>
+                <a16:creationId xmlns:a16="http://schemas.microsoft.com/office/drawing/2014/main" id="{C593B851-EC5B-49E0-B965-9AAC6F2830FA}"/>
               </a:ext>
             </a:extLst>
           </p:cNvPr>
@@ -3303,7 +3308,7 @@
           <p:cNvPr id="15" name="method-label-2">
             <a:extLst xmlns:a="http://schemas.openxmlformats.org/drawingml/2006/main">
               <a:ext uri="{FF2B5EF4-FFF2-40B4-BE49-F238E27FC236}">
-                <a16:creationId xmlns:a16="http://schemas.microsoft.com/office/drawing/2014/main" id="{AD800374-106B-46EB-9D63-9C17163CE4A1}"/>
+                <a16:creationId xmlns:a16="http://schemas.microsoft.com/office/drawing/2014/main" id="{6D6C3CDF-9939-4F70-A3AD-0F405743B03D}"/>
               </a:ext>
             </a:extLst>
           </p:cNvPr>
@@ -3353,7 +3358,7 @@
           <p:cNvPr id="16" name="method-copy-2">
             <a:extLst xmlns:a="http://schemas.openxmlformats.org/drawingml/2006/main">
               <a:ext uri="{FF2B5EF4-FFF2-40B4-BE49-F238E27FC236}">
-                <a16:creationId xmlns:a16="http://schemas.microsoft.com/office/drawing/2014/main" id="{A4FBA87C-AD49-443C-8BBA-76B9631ADC98}"/>
+                <a16:creationId xmlns:a16="http://schemas.microsoft.com/office/drawing/2014/main" id="{ADFB3FAF-1DF6-4DF6-9209-68BA2E4681E2}"/>
               </a:ext>
             </a:extLst>
           </p:cNvPr>
@@ -3403,7 +3408,7 @@
           <p:cNvPr id="17" name="method-footer">
             <a:extLst xmlns:a="http://schemas.openxmlformats.org/drawingml/2006/main">
               <a:ext uri="{FF2B5EF4-FFF2-40B4-BE49-F238E27FC236}">
-                <a16:creationId xmlns:a16="http://schemas.microsoft.com/office/drawing/2014/main" id="{694C127D-01BC-4053-B3E3-1E1CC5EC5098}"/>
+                <a16:creationId xmlns:a16="http://schemas.microsoft.com/office/drawing/2014/main" id="{DF72C5FD-663E-46A5-B9E4-B53B77CBC1EA}"/>
               </a:ext>
             </a:extLst>
           </p:cNvPr>
@@ -3443,7 +3448,7 @@
                   <a:srgbClr val="111827"/>
                 </a:solidFill>
               </a:rPr>
-              <a:t>Held-out origin groups prevent the model from memorizing local origin patterns.</a:t>
+              <a:t>Households stay in one fold; harder tests also withhold whole origins and a later wave.</a:t>
             </a:r>
           </a:p>
         </p:txBody>
@@ -3451,7 +3456,7 @@
     </p:spTree>
     <p:extLst>
       <p:ext uri="{BB962C8B-B14F-4D97-AF65-F5344CB8AC3E}">
-        <p14:creationId xmlns:p14="http://schemas.microsoft.com/office/powerpoint/2010/main" val="462506405"/>
+        <p14:creationId xmlns:p14="http://schemas.microsoft.com/office/powerpoint/2010/main" val="1817214239"/>
       </p:ext>
     </p:extLst>
   </p:cSld>
@@ -3482,7 +3487,7 @@
           <p:cNvPr id="13" name="kicker-4">
             <a:extLst xmlns:a="http://schemas.openxmlformats.org/drawingml/2006/main">
               <a:ext uri="{FF2B5EF4-FFF2-40B4-BE49-F238E27FC236}">
-                <a16:creationId xmlns:a16="http://schemas.microsoft.com/office/drawing/2014/main" id="{E09FAD99-DCDD-40EB-9B5A-84D46B6477E4}"/>
+                <a16:creationId xmlns:a16="http://schemas.microsoft.com/office/drawing/2014/main" id="{D84DC767-481C-4202-8051-8C580AE7061F}"/>
               </a:ext>
             </a:extLst>
           </p:cNvPr>
@@ -3522,7 +3527,7 @@
                   <a:srgbClr val="1877C9"/>
                 </a:solidFill>
               </a:rPr>
-              <a:t>MAIN RESULT</a:t>
+              <a:t>INDEPENDENT REPLICATION</a:t>
             </a:r>
           </a:p>
         </p:txBody>
@@ -3532,7 +3537,7 @@
           <p:cNvPr id="2" name="title-4">
             <a:extLst xmlns:a="http://schemas.openxmlformats.org/drawingml/2006/main">
               <a:ext uri="{FF2B5EF4-FFF2-40B4-BE49-F238E27FC236}">
-                <a16:creationId xmlns:a16="http://schemas.microsoft.com/office/drawing/2014/main" id="{17D41AE2-C4C6-4F08-96C3-D394AFBDA6CE}"/>
+                <a16:creationId xmlns:a16="http://schemas.microsoft.com/office/drawing/2014/main" id="{FABD6C99-A6B5-4922-80D3-2FE3D8516F7F}"/>
               </a:ext>
             </a:extLst>
           </p:cNvPr>
@@ -3572,7 +3577,7 @@
                   <a:srgbClr val="111827"/>
                 </a:solidFill>
               </a:rPr>
-              <a:t>GIS raises held-out destination probability in both surveys</a:t>
+              <a:t>The BIHS result survives unseen origins and a later wave</a:t>
             </a:r>
           </a:p>
         </p:txBody>
@@ -3582,7 +3587,7 @@
           <p:cNvPr id="3" name="header-rule-4">
             <a:extLst xmlns:a="http://schemas.openxmlformats.org/drawingml/2006/main">
               <a:ext uri="{FF2B5EF4-FFF2-40B4-BE49-F238E27FC236}">
-                <a16:creationId xmlns:a16="http://schemas.microsoft.com/office/drawing/2014/main" id="{565C21B5-E87D-430C-8689-8DB1B5D48AC2}"/>
+                <a16:creationId xmlns:a16="http://schemas.microsoft.com/office/drawing/2014/main" id="{1E4D4509-325A-4AA7-92F3-C1767DE0E563}"/>
               </a:ext>
             </a:extLst>
           </p:cNvPr>
@@ -3613,7 +3618,7 @@
           <p:cNvPr id="4" name="number-4">
             <a:extLst xmlns:a="http://schemas.openxmlformats.org/drawingml/2006/main">
               <a:ext uri="{FF2B5EF4-FFF2-40B4-BE49-F238E27FC236}">
-                <a16:creationId xmlns:a16="http://schemas.microsoft.com/office/drawing/2014/main" id="{5867C425-9383-44D3-8AF7-0AC1DDDB799C}"/>
+                <a16:creationId xmlns:a16="http://schemas.microsoft.com/office/drawing/2014/main" id="{F05E3FB8-6C64-4205-ACD0-1698980556CE}"/>
               </a:ext>
             </a:extLst>
           </p:cNvPr>
@@ -3667,13 +3672,13 @@
           <p:nvPr/>
         </p:nvPicPr>
         <p:blipFill>
-          <a:blip xmlns:r="http://schemas.openxmlformats.org/officeDocument/2006/relationships" xmlns:a="http://schemas.openxmlformats.org/drawingml/2006/main" r:embed="R769d9f41386d4bee"/>
+          <a:blip xmlns:r="http://schemas.openxmlformats.org/officeDocument/2006/relationships" xmlns:a="http://schemas.openxmlformats.org/drawingml/2006/main" r:embed="R35575bee5bc2433b"/>
           <a:stretch xmlns:a="http://schemas.openxmlformats.org/drawingml/2006/main"/>
         </p:blipFill>
         <p:spPr>
           <a:xfrm xmlns:a="http://schemas.openxmlformats.org/drawingml/2006/main">
-            <a:off x="845626" y="1695450"/>
-            <a:ext cx="6538347" cy="4286250"/>
+            <a:off x="495300" y="1709457"/>
+            <a:ext cx="7239000" cy="4258235"/>
           </a:xfrm>
           <a:prstGeom xmlns:a="http://schemas.openxmlformats.org/drawingml/2006/main" prst="rect">
             <a:avLst/>
@@ -3685,7 +3690,7 @@
           <p:cNvPr id="6" name="result-rail">
             <a:extLst xmlns:a="http://schemas.openxmlformats.org/drawingml/2006/main">
               <a:ext uri="{FF2B5EF4-FFF2-40B4-BE49-F238E27FC236}">
-                <a16:creationId xmlns:a16="http://schemas.microsoft.com/office/drawing/2014/main" id="{439950BF-D5E5-4004-AED7-718B0BACA447}"/>
+                <a16:creationId xmlns:a16="http://schemas.microsoft.com/office/drawing/2014/main" id="{20E856CB-F67F-4C54-9B90-FEAD6309BE1A}"/>
               </a:ext>
             </a:extLst>
           </p:cNvPr>
@@ -3716,7 +3721,7 @@
           <p:cNvPr id="7" name="result-stat-1">
             <a:extLst xmlns:a="http://schemas.openxmlformats.org/drawingml/2006/main">
               <a:ext uri="{FF2B5EF4-FFF2-40B4-BE49-F238E27FC236}">
-                <a16:creationId xmlns:a16="http://schemas.microsoft.com/office/drawing/2014/main" id="{3D82ECFE-DE5D-4185-8B16-412307569454}"/>
+                <a16:creationId xmlns:a16="http://schemas.microsoft.com/office/drawing/2014/main" id="{B93EAF3E-C820-4364-A444-6063515C63E7}"/>
               </a:ext>
             </a:extLst>
           </p:cNvPr>
@@ -3756,7 +3761,7 @@
                   <a:srgbClr val="1877C9"/>
                 </a:solidFill>
               </a:rPr>
-              <a:t>+10.8 pp</a:t>
+              <a:t>+0.101</a:t>
             </a:r>
           </a:p>
         </p:txBody>
@@ -3766,7 +3771,7 @@
           <p:cNvPr id="8" name="result-desc-1">
             <a:extLst xmlns:a="http://schemas.openxmlformats.org/drawingml/2006/main">
               <a:ext uri="{FF2B5EF4-FFF2-40B4-BE49-F238E27FC236}">
-                <a16:creationId xmlns:a16="http://schemas.microsoft.com/office/drawing/2014/main" id="{9F968DE4-2337-4B3D-9C1A-DA8D25F3681C}"/>
+                <a16:creationId xmlns:a16="http://schemas.microsoft.com/office/drawing/2014/main" id="{A04A86F5-74BE-4E9B-A639-070E7196740A}"/>
               </a:ext>
             </a:extLst>
           </p:cNvPr>
@@ -3806,7 +3811,7 @@
                   <a:srgbClr val="556070"/>
                 </a:solidFill>
               </a:rPr>
-              <a:t>BEMP shock-linked moves</a:t>
+              <a:t>Leave one origin out</a:t>
             </a:r>
           </a:p>
           <a:p xmlns:a="http://schemas.openxmlformats.org/drawingml/2006/main">
@@ -3823,7 +3828,7 @@
                   <a:srgbClr val="556070"/>
                 </a:solidFill>
               </a:rPr>
-              <a:t>184 events</a:t>
+              <a:t>1,857 BIHS migrants</a:t>
             </a:r>
           </a:p>
         </p:txBody>
@@ -3833,7 +3838,7 @@
           <p:cNvPr id="9" name="result-rule">
             <a:extLst xmlns:a="http://schemas.openxmlformats.org/drawingml/2006/main">
               <a:ext uri="{FF2B5EF4-FFF2-40B4-BE49-F238E27FC236}">
-                <a16:creationId xmlns:a16="http://schemas.microsoft.com/office/drawing/2014/main" id="{4F1C9514-5564-4294-8A74-05D41048A2BD}"/>
+                <a16:creationId xmlns:a16="http://schemas.microsoft.com/office/drawing/2014/main" id="{14E9D1B7-87D2-45C0-A91C-013012C1A772}"/>
               </a:ext>
             </a:extLst>
           </p:cNvPr>
@@ -3864,7 +3869,7 @@
           <p:cNvPr id="10" name="result-stat-2">
             <a:extLst xmlns:a="http://schemas.openxmlformats.org/drawingml/2006/main">
               <a:ext uri="{FF2B5EF4-FFF2-40B4-BE49-F238E27FC236}">
-                <a16:creationId xmlns:a16="http://schemas.microsoft.com/office/drawing/2014/main" id="{83053926-72E7-4492-BCDD-49242CD37AFE}"/>
+                <a16:creationId xmlns:a16="http://schemas.microsoft.com/office/drawing/2014/main" id="{A4977E5E-AD64-4359-A69C-72B01FA109AE}"/>
               </a:ext>
             </a:extLst>
           </p:cNvPr>
@@ -3904,7 +3909,7 @@
                   <a:srgbClr val="147D64"/>
                 </a:solidFill>
               </a:rPr>
-              <a:t>+9.8 pp</a:t>
+              <a:t>+0.094</a:t>
             </a:r>
           </a:p>
         </p:txBody>
@@ -3914,7 +3919,7 @@
           <p:cNvPr id="11" name="result-desc-2">
             <a:extLst xmlns:a="http://schemas.openxmlformats.org/drawingml/2006/main">
               <a:ext uri="{FF2B5EF4-FFF2-40B4-BE49-F238E27FC236}">
-                <a16:creationId xmlns:a16="http://schemas.microsoft.com/office/drawing/2014/main" id="{4B324D2C-AC66-41F7-92B5-CC1E425B9FAB}"/>
+                <a16:creationId xmlns:a16="http://schemas.microsoft.com/office/drawing/2014/main" id="{7D15F0F9-67B8-4CDF-9277-0FAB0F087B5E}"/>
               </a:ext>
             </a:extLst>
           </p:cNvPr>
@@ -3954,7 +3959,7 @@
                   <a:srgbClr val="556070"/>
                 </a:solidFill>
               </a:rPr>
-              <a:t>BIHS erosion-linked moves</a:t>
+              <a:t>Train 2015, test 2018–19</a:t>
             </a:r>
           </a:p>
           <a:p xmlns:a="http://schemas.openxmlformats.org/drawingml/2006/main">
@@ -3971,7 +3976,7 @@
                   <a:srgbClr val="556070"/>
                 </a:solidFill>
               </a:rPr>
-              <a:t>123 events</a:t>
+              <a:t>1,383 later-wave migrants</a:t>
             </a:r>
           </a:p>
         </p:txBody>
@@ -3981,7 +3986,7 @@
           <p:cNvPr id="12" name="result-note">
             <a:extLst xmlns:a="http://schemas.openxmlformats.org/drawingml/2006/main">
               <a:ext uri="{FF2B5EF4-FFF2-40B4-BE49-F238E27FC236}">
-                <a16:creationId xmlns:a16="http://schemas.microsoft.com/office/drawing/2014/main" id="{615E4B6C-2566-4CEF-9F9A-6F40F84F7196}"/>
+                <a16:creationId xmlns:a16="http://schemas.microsoft.com/office/drawing/2014/main" id="{470FBCEA-A849-4985-A5D1-81DE49B822C2}"/>
               </a:ext>
             </a:extLst>
           </p:cNvPr>
@@ -4021,7 +4026,7 @@
                   <a:srgbClr val="556070"/>
                 </a:solidFill>
               </a:rPr>
-              <a:t>Percentage-point gains in the probability assigned to the destination actually chosen.</a:t>
+              <a:t>Held-out log-loss improvement over fitted gravity. Positive values favor GIS.</a:t>
             </a:r>
           </a:p>
         </p:txBody>
@@ -4029,7 +4034,7 @@
     </p:spTree>
     <p:extLst>
       <p:ext uri="{BB962C8B-B14F-4D97-AF65-F5344CB8AC3E}">
-        <p14:creationId xmlns:p14="http://schemas.microsoft.com/office/powerpoint/2010/main" val="1472495667"/>
+        <p14:creationId xmlns:p14="http://schemas.microsoft.com/office/powerpoint/2010/main" val="241284188"/>
       </p:ext>
     </p:extLst>
   </p:cSld>
@@ -4060,7 +4065,7 @@
           <p:cNvPr id="11" name="kicker-5">
             <a:extLst xmlns:a="http://schemas.openxmlformats.org/drawingml/2006/main">
               <a:ext uri="{FF2B5EF4-FFF2-40B4-BE49-F238E27FC236}">
-                <a16:creationId xmlns:a16="http://schemas.microsoft.com/office/drawing/2014/main" id="{A15D3EA3-B9FA-4F42-9A1D-8FD159A56DF9}"/>
+                <a16:creationId xmlns:a16="http://schemas.microsoft.com/office/drawing/2014/main" id="{9852AA71-C249-4EF5-9865-753DE544F1DA}"/>
               </a:ext>
             </a:extLst>
           </p:cNvPr>
@@ -4100,7 +4105,7 @@
                   <a:srgbClr val="1877C9"/>
                 </a:solidFill>
               </a:rPr>
-              <a:t>EXTERNAL VALIDATION</a:t>
+              <a:t>CLIMATE-SPECIFIC EVIDENCE</a:t>
             </a:r>
           </a:p>
         </p:txBody>
@@ -4110,7 +4115,7 @@
           <p:cNvPr id="2" name="title-5">
             <a:extLst xmlns:a="http://schemas.openxmlformats.org/drawingml/2006/main">
               <a:ext uri="{FF2B5EF4-FFF2-40B4-BE49-F238E27FC236}">
-                <a16:creationId xmlns:a16="http://schemas.microsoft.com/office/drawing/2014/main" id="{CACE2792-E06E-4A40-B78E-8876CDD06EF9}"/>
+                <a16:creationId xmlns:a16="http://schemas.microsoft.com/office/drawing/2014/main" id="{37D4D130-B1FF-4CB0-90F9-FA97189E4FB3}"/>
               </a:ext>
             </a:extLst>
           </p:cNvPr>
@@ -4150,7 +4155,7 @@
                   <a:srgbClr val="111827"/>
                 </a:solidFill>
               </a:rPr>
-              <a:t>Destination ranking travels; stay-versus-leave does not</a:t>
+              <a:t>Two climate samples reproduce the grouped gain</a:t>
             </a:r>
           </a:p>
         </p:txBody>
@@ -4160,7 +4165,7 @@
           <p:cNvPr id="3" name="header-rule-5">
             <a:extLst xmlns:a="http://schemas.openxmlformats.org/drawingml/2006/main">
               <a:ext uri="{FF2B5EF4-FFF2-40B4-BE49-F238E27FC236}">
-                <a16:creationId xmlns:a16="http://schemas.microsoft.com/office/drawing/2014/main" id="{814538AD-3C6A-4D3F-A121-0560323CA196}"/>
+                <a16:creationId xmlns:a16="http://schemas.microsoft.com/office/drawing/2014/main" id="{3A72386C-33F7-4182-A8B0-45448A0E1AD3}"/>
               </a:ext>
             </a:extLst>
           </p:cNvPr>
@@ -4191,7 +4196,7 @@
           <p:cNvPr id="4" name="number-5">
             <a:extLst xmlns:a="http://schemas.openxmlformats.org/drawingml/2006/main">
               <a:ext uri="{FF2B5EF4-FFF2-40B4-BE49-F238E27FC236}">
-                <a16:creationId xmlns:a16="http://schemas.microsoft.com/office/drawing/2014/main" id="{BA52AE27-CA87-4BC5-9449-663788BD6440}"/>
+                <a16:creationId xmlns:a16="http://schemas.microsoft.com/office/drawing/2014/main" id="{8ED75F91-E8DB-4E34-9356-3C8C31862E1B}"/>
               </a:ext>
             </a:extLst>
           </p:cNvPr>
@@ -4245,13 +4250,13 @@
           <p:nvPr/>
         </p:nvPicPr>
         <p:blipFill>
-          <a:blip xmlns:r="http://schemas.openxmlformats.org/officeDocument/2006/relationships" xmlns:a="http://schemas.openxmlformats.org/drawingml/2006/main" r:embed="R056c63e85a674256"/>
+          <a:blip xmlns:r="http://schemas.openxmlformats.org/officeDocument/2006/relationships" xmlns:a="http://schemas.openxmlformats.org/drawingml/2006/main" r:embed="R7d01dc3e1d2b4062"/>
           <a:stretch xmlns:a="http://schemas.openxmlformats.org/drawingml/2006/main"/>
         </p:blipFill>
         <p:spPr>
           <a:xfrm xmlns:a="http://schemas.openxmlformats.org/drawingml/2006/main">
-            <a:off x="495300" y="1773331"/>
-            <a:ext cx="6762750" cy="3978088"/>
+            <a:off x="752798" y="1714500"/>
+            <a:ext cx="6247754" cy="4095750"/>
           </a:xfrm>
           <a:prstGeom xmlns:a="http://schemas.openxmlformats.org/drawingml/2006/main" prst="rect">
             <a:avLst/>
@@ -4263,7 +4268,7 @@
           <p:cNvPr id="6" name="validation-head">
             <a:extLst xmlns:a="http://schemas.openxmlformats.org/drawingml/2006/main">
               <a:ext uri="{FF2B5EF4-FFF2-40B4-BE49-F238E27FC236}">
-                <a16:creationId xmlns:a16="http://schemas.microsoft.com/office/drawing/2014/main" id="{7DCCA5FA-21AD-406F-A47C-1C06C7AC6E47}"/>
+                <a16:creationId xmlns:a16="http://schemas.microsoft.com/office/drawing/2014/main" id="{573AEA07-98F7-412F-BAFE-BEAD7DF7133A}"/>
               </a:ext>
             </a:extLst>
           </p:cNvPr>
@@ -4303,7 +4308,7 @@
                   <a:srgbClr val="111827"/>
                 </a:solidFill>
               </a:rPr>
-              <a:t>What survives the harder test</a:t>
+              <a:t>Same model, different surveys</a:t>
             </a:r>
           </a:p>
         </p:txBody>
@@ -4313,7 +4318,7 @@
           <p:cNvPr id="7" name="validation-blue">
             <a:extLst xmlns:a="http://schemas.openxmlformats.org/drawingml/2006/main">
               <a:ext uri="{FF2B5EF4-FFF2-40B4-BE49-F238E27FC236}">
-                <a16:creationId xmlns:a16="http://schemas.microsoft.com/office/drawing/2014/main" id="{38AA453D-D1DD-479F-B057-DC372C72D66A}"/>
+                <a16:creationId xmlns:a16="http://schemas.microsoft.com/office/drawing/2014/main" id="{A0753A9D-15D5-43DD-AF06-32279B2D7434}"/>
               </a:ext>
             </a:extLst>
           </p:cNvPr>
@@ -4344,7 +4349,7 @@
           <p:cNvPr id="8" name="validation-good">
             <a:extLst xmlns:a="http://schemas.openxmlformats.org/drawingml/2006/main">
               <a:ext uri="{FF2B5EF4-FFF2-40B4-BE49-F238E27FC236}">
-                <a16:creationId xmlns:a16="http://schemas.microsoft.com/office/drawing/2014/main" id="{EEAD4349-AD66-4665-84D1-96EF4295EFA0}"/>
+                <a16:creationId xmlns:a16="http://schemas.microsoft.com/office/drawing/2014/main" id="{342BC1BA-B916-4696-A3F7-9EA914371B01}"/>
               </a:ext>
             </a:extLst>
           </p:cNvPr>
@@ -4384,7 +4389,7 @@
                   <a:srgbClr val="111827"/>
                 </a:solidFill>
               </a:rPr>
-              <a:t>Among people who moved, GIS features continue to improve destination ranking across many held-out origins.</a:t>
+              <a:t>BIHS erosion moves: +0.098 across 123 relocations from 29 origins.</a:t>
             </a:r>
           </a:p>
         </p:txBody>
@@ -4394,7 +4399,7 @@
           <p:cNvPr id="9" name="validation-orange">
             <a:extLst xmlns:a="http://schemas.openxmlformats.org/drawingml/2006/main">
               <a:ext uri="{FF2B5EF4-FFF2-40B4-BE49-F238E27FC236}">
-                <a16:creationId xmlns:a16="http://schemas.microsoft.com/office/drawing/2014/main" id="{D06E6E16-109D-4223-9871-C7106A57C213}"/>
+                <a16:creationId xmlns:a16="http://schemas.microsoft.com/office/drawing/2014/main" id="{4064FBD9-B662-4297-84B9-EA45A9AC403E}"/>
               </a:ext>
             </a:extLst>
           </p:cNvPr>
@@ -4425,7 +4430,7 @@
           <p:cNvPr id="10" name="validation-caution">
             <a:extLst xmlns:a="http://schemas.openxmlformats.org/drawingml/2006/main">
               <a:ext uri="{FF2B5EF4-FFF2-40B4-BE49-F238E27FC236}">
-                <a16:creationId xmlns:a16="http://schemas.microsoft.com/office/drawing/2014/main" id="{09B8D519-C50B-4BEF-AB8D-22B250C9BCA5}"/>
+                <a16:creationId xmlns:a16="http://schemas.microsoft.com/office/drawing/2014/main" id="{DA8D897A-29D5-45F7-B91C-91C497B0EC1D}"/>
               </a:ext>
             </a:extLst>
           </p:cNvPr>
@@ -4465,7 +4470,7 @@
                   <a:srgbClr val="111827"/>
                 </a:solidFill>
               </a:rPr>
-              <a:t>A model trained on one origin does not reliably predict who leaves another origin. That is a different scientific problem.</a:t>
+              <a:t>BEMP shock-linked moves: +0.108 across 184 later relocations from 7 origins.</a:t>
             </a:r>
           </a:p>
         </p:txBody>
@@ -4473,7 +4478,7 @@
     </p:spTree>
     <p:extLst>
       <p:ext uri="{BB962C8B-B14F-4D97-AF65-F5344CB8AC3E}">
-        <p14:creationId xmlns:p14="http://schemas.microsoft.com/office/powerpoint/2010/main" val="439433900"/>
+        <p14:creationId xmlns:p14="http://schemas.microsoft.com/office/powerpoint/2010/main" val="958167477"/>
       </p:ext>
     </p:extLst>
   </p:cSld>
@@ -4504,7 +4509,7 @@
           <p:cNvPr id="15" name="kicker-6">
             <a:extLst xmlns:a="http://schemas.openxmlformats.org/drawingml/2006/main">
               <a:ext uri="{FF2B5EF4-FFF2-40B4-BE49-F238E27FC236}">
-                <a16:creationId xmlns:a16="http://schemas.microsoft.com/office/drawing/2014/main" id="{63C705D8-CC9B-4AEA-80D7-781217C09D17}"/>
+                <a16:creationId xmlns:a16="http://schemas.microsoft.com/office/drawing/2014/main" id="{3D2C7226-E098-41DD-97A1-8D831AAD6454}"/>
               </a:ext>
             </a:extLst>
           </p:cNvPr>
@@ -4554,7 +4559,7 @@
           <p:cNvPr id="2" name="title-6">
             <a:extLst xmlns:a="http://schemas.openxmlformats.org/drawingml/2006/main">
               <a:ext uri="{FF2B5EF4-FFF2-40B4-BE49-F238E27FC236}">
-                <a16:creationId xmlns:a16="http://schemas.microsoft.com/office/drawing/2014/main" id="{6B839A03-2574-440A-BF42-AA4408A94FC0}"/>
+                <a16:creationId xmlns:a16="http://schemas.microsoft.com/office/drawing/2014/main" id="{BEE6FDC4-0C24-4408-AC75-58164960E701}"/>
               </a:ext>
             </a:extLst>
           </p:cNvPr>
@@ -4604,7 +4609,7 @@
           <p:cNvPr id="3" name="header-rule-6">
             <a:extLst xmlns:a="http://schemas.openxmlformats.org/drawingml/2006/main">
               <a:ext uri="{FF2B5EF4-FFF2-40B4-BE49-F238E27FC236}">
-                <a16:creationId xmlns:a16="http://schemas.microsoft.com/office/drawing/2014/main" id="{744B27A8-4669-4F0E-BAED-A0F7F48B17DB}"/>
+                <a16:creationId xmlns:a16="http://schemas.microsoft.com/office/drawing/2014/main" id="{E7BAB5C7-78AD-468E-A51F-226A36A116B0}"/>
               </a:ext>
             </a:extLst>
           </p:cNvPr>
@@ -4635,7 +4640,7 @@
           <p:cNvPr id="4" name="number-6">
             <a:extLst xmlns:a="http://schemas.openxmlformats.org/drawingml/2006/main">
               <a:ext uri="{FF2B5EF4-FFF2-40B4-BE49-F238E27FC236}">
-                <a16:creationId xmlns:a16="http://schemas.microsoft.com/office/drawing/2014/main" id="{A210DDC8-6C02-4C9B-ACC1-9FC4E0B9DD43}"/>
+                <a16:creationId xmlns:a16="http://schemas.microsoft.com/office/drawing/2014/main" id="{4FC1ED5D-5AB1-4022-BB0E-5453575A44FD}"/>
               </a:ext>
             </a:extLst>
           </p:cNvPr>
@@ -4685,7 +4690,7 @@
           <p:cNvPr id="5" name="limits-lead">
             <a:extLst xmlns:a="http://schemas.openxmlformats.org/drawingml/2006/main">
               <a:ext uri="{FF2B5EF4-FFF2-40B4-BE49-F238E27FC236}">
-                <a16:creationId xmlns:a16="http://schemas.microsoft.com/office/drawing/2014/main" id="{1DF5174F-7908-412B-8F73-C24619F4CA5A}"/>
+                <a16:creationId xmlns:a16="http://schemas.microsoft.com/office/drawing/2014/main" id="{BE123AD4-948B-462B-BBF7-B13252E71A5D}"/>
               </a:ext>
             </a:extLst>
           </p:cNvPr>
@@ -4735,7 +4740,7 @@
           <p:cNvPr id="6" name="limit-panel-0">
             <a:extLst xmlns:a="http://schemas.openxmlformats.org/drawingml/2006/main">
               <a:ext uri="{FF2B5EF4-FFF2-40B4-BE49-F238E27FC236}">
-                <a16:creationId xmlns:a16="http://schemas.microsoft.com/office/drawing/2014/main" id="{F8F2F2D7-F95F-4503-ADB2-6D93787C0E48}"/>
+                <a16:creationId xmlns:a16="http://schemas.microsoft.com/office/drawing/2014/main" id="{E6FCBA04-99FB-4483-A2C3-A50F3E094BE4}"/>
               </a:ext>
             </a:extLst>
           </p:cNvPr>
@@ -4766,7 +4771,7 @@
           <p:cNvPr id="7" name="limit-head-0">
             <a:extLst xmlns:a="http://schemas.openxmlformats.org/drawingml/2006/main">
               <a:ext uri="{FF2B5EF4-FFF2-40B4-BE49-F238E27FC236}">
-                <a16:creationId xmlns:a16="http://schemas.microsoft.com/office/drawing/2014/main" id="{6E4937A7-5578-44C1-A05F-6385B168099D}"/>
+                <a16:creationId xmlns:a16="http://schemas.microsoft.com/office/drawing/2014/main" id="{0602F98D-1F68-49F0-BB70-F8202AD95DA3}"/>
               </a:ext>
             </a:extLst>
           </p:cNvPr>
@@ -4816,7 +4821,7 @@
           <p:cNvPr id="8" name="limit-body-0">
             <a:extLst xmlns:a="http://schemas.openxmlformats.org/drawingml/2006/main">
               <a:ext uri="{FF2B5EF4-FFF2-40B4-BE49-F238E27FC236}">
-                <a16:creationId xmlns:a16="http://schemas.microsoft.com/office/drawing/2014/main" id="{B014988F-4021-4D4C-B535-BD78C5F22E67}"/>
+                <a16:creationId xmlns:a16="http://schemas.microsoft.com/office/drawing/2014/main" id="{FA2BEE21-DB58-4304-BFBB-C40932559BFD}"/>
               </a:ext>
             </a:extLst>
           </p:cNvPr>
@@ -4866,7 +4871,7 @@
           <p:cNvPr id="9" name="limit-panel-1">
             <a:extLst xmlns:a="http://schemas.openxmlformats.org/drawingml/2006/main">
               <a:ext uri="{FF2B5EF4-FFF2-40B4-BE49-F238E27FC236}">
-                <a16:creationId xmlns:a16="http://schemas.microsoft.com/office/drawing/2014/main" id="{E16F7C16-0DC2-43EA-A520-B9E3F49B6370}"/>
+                <a16:creationId xmlns:a16="http://schemas.microsoft.com/office/drawing/2014/main" id="{2FDE4DDD-EF6C-40E5-B9AC-EA6FAFEB87CA}"/>
               </a:ext>
             </a:extLst>
           </p:cNvPr>
@@ -4897,7 +4902,7 @@
           <p:cNvPr id="10" name="limit-head-1">
             <a:extLst xmlns:a="http://schemas.openxmlformats.org/drawingml/2006/main">
               <a:ext uri="{FF2B5EF4-FFF2-40B4-BE49-F238E27FC236}">
-                <a16:creationId xmlns:a16="http://schemas.microsoft.com/office/drawing/2014/main" id="{1D8C2FD5-D355-4F83-9AFB-21240B69CDE2}"/>
+                <a16:creationId xmlns:a16="http://schemas.microsoft.com/office/drawing/2014/main" id="{94E4E855-C8ED-442A-AA0C-36259978982B}"/>
               </a:ext>
             </a:extLst>
           </p:cNvPr>
@@ -4947,7 +4952,7 @@
           <p:cNvPr id="11" name="limit-body-1">
             <a:extLst xmlns:a="http://schemas.openxmlformats.org/drawingml/2006/main">
               <a:ext uri="{FF2B5EF4-FFF2-40B4-BE49-F238E27FC236}">
-                <a16:creationId xmlns:a16="http://schemas.microsoft.com/office/drawing/2014/main" id="{5F7706E8-C9A8-4505-A8D7-FD79BCD7E554}"/>
+                <a16:creationId xmlns:a16="http://schemas.microsoft.com/office/drawing/2014/main" id="{BFC95C5E-04A8-4706-A528-37A93F6F1590}"/>
               </a:ext>
             </a:extLst>
           </p:cNvPr>
@@ -4997,7 +5002,7 @@
           <p:cNvPr id="12" name="limit-panel-2">
             <a:extLst xmlns:a="http://schemas.openxmlformats.org/drawingml/2006/main">
               <a:ext uri="{FF2B5EF4-FFF2-40B4-BE49-F238E27FC236}">
-                <a16:creationId xmlns:a16="http://schemas.microsoft.com/office/drawing/2014/main" id="{7D5D29FE-681A-419F-87D3-05EB16E2FCEA}"/>
+                <a16:creationId xmlns:a16="http://schemas.microsoft.com/office/drawing/2014/main" id="{B8BC5DC1-D9E8-4198-84BA-F5AEF276CACC}"/>
               </a:ext>
             </a:extLst>
           </p:cNvPr>
@@ -5028,7 +5033,7 @@
           <p:cNvPr id="13" name="limit-head-2">
             <a:extLst xmlns:a="http://schemas.openxmlformats.org/drawingml/2006/main">
               <a:ext uri="{FF2B5EF4-FFF2-40B4-BE49-F238E27FC236}">
-                <a16:creationId xmlns:a16="http://schemas.microsoft.com/office/drawing/2014/main" id="{BAFAC390-47D6-4FBE-84C5-B9A21349B6D7}"/>
+                <a16:creationId xmlns:a16="http://schemas.microsoft.com/office/drawing/2014/main" id="{422A14C8-83F2-4D88-8CA3-7DF9E59C5095}"/>
               </a:ext>
             </a:extLst>
           </p:cNvPr>
@@ -5078,7 +5083,7 @@
           <p:cNvPr id="14" name="limit-body-2">
             <a:extLst xmlns:a="http://schemas.openxmlformats.org/drawingml/2006/main">
               <a:ext uri="{FF2B5EF4-FFF2-40B4-BE49-F238E27FC236}">
-                <a16:creationId xmlns:a16="http://schemas.microsoft.com/office/drawing/2014/main" id="{6044B0FE-366A-4730-B25C-7FF4B9E62699}"/>
+                <a16:creationId xmlns:a16="http://schemas.microsoft.com/office/drawing/2014/main" id="{8CB269B9-321A-4C88-9DD1-20EA7A2019DB}"/>
               </a:ext>
             </a:extLst>
           </p:cNvPr>
@@ -5126,7 +5131,7 @@
     </p:spTree>
     <p:extLst>
       <p:ext uri="{BB962C8B-B14F-4D97-AF65-F5344CB8AC3E}">
-        <p14:creationId xmlns:p14="http://schemas.microsoft.com/office/powerpoint/2010/main" val="421608105"/>
+        <p14:creationId xmlns:p14="http://schemas.microsoft.com/office/powerpoint/2010/main" val="2017803933"/>
       </p:ext>
     </p:extLst>
   </p:cSld>
@@ -5157,7 +5162,7 @@
           <p:cNvPr id="7" name="close-kicker">
             <a:extLst xmlns:a="http://schemas.openxmlformats.org/drawingml/2006/main">
               <a:ext uri="{FF2B5EF4-FFF2-40B4-BE49-F238E27FC236}">
-                <a16:creationId xmlns:a16="http://schemas.microsoft.com/office/drawing/2014/main" id="{9602BA35-2DC4-4863-8368-32811D925D64}"/>
+                <a16:creationId xmlns:a16="http://schemas.microsoft.com/office/drawing/2014/main" id="{0ED939B1-D5F4-47A9-AAF2-D44C0EAFCE82}"/>
               </a:ext>
             </a:extLst>
           </p:cNvPr>
@@ -5207,7 +5212,7 @@
           <p:cNvPr id="2" name="close-title">
             <a:extLst xmlns:a="http://schemas.openxmlformats.org/drawingml/2006/main">
               <a:ext uri="{FF2B5EF4-FFF2-40B4-BE49-F238E27FC236}">
-                <a16:creationId xmlns:a16="http://schemas.microsoft.com/office/drawing/2014/main" id="{6E77A870-90D2-4263-9F93-9153F72FBCFD}"/>
+                <a16:creationId xmlns:a16="http://schemas.microsoft.com/office/drawing/2014/main" id="{6AF09CB6-B72E-4CF3-806A-755E910B578C}"/>
               </a:ext>
             </a:extLst>
           </p:cNvPr>
@@ -5247,7 +5252,7 @@
                   <a:srgbClr val="FFFFFF"/>
                 </a:solidFill>
               </a:rPr>
-              <a:t>A climate shock changes where a family must choose from.</a:t>
+              <a:t>After a climate-linked move, destination geography still matters.</a:t>
             </a:r>
           </a:p>
         </p:txBody>
@@ -5257,7 +5262,7 @@
           <p:cNvPr id="3" name="close-body">
             <a:extLst xmlns:a="http://schemas.openxmlformats.org/drawingml/2006/main">
               <a:ext uri="{FF2B5EF4-FFF2-40B4-BE49-F238E27FC236}">
-                <a16:creationId xmlns:a16="http://schemas.microsoft.com/office/drawing/2014/main" id="{7BF546FE-6BF6-4F9F-8141-58F0A5C3580E}"/>
+                <a16:creationId xmlns:a16="http://schemas.microsoft.com/office/drawing/2014/main" id="{FA891BFA-9D99-4DEB-B933-C9662B90BC21}"/>
               </a:ext>
             </a:extLst>
           </p:cNvPr>
@@ -5307,7 +5312,7 @@
           <p:cNvPr id="4" name="close-rule">
             <a:extLst xmlns:a="http://schemas.openxmlformats.org/drawingml/2006/main">
               <a:ext uri="{FF2B5EF4-FFF2-40B4-BE49-F238E27FC236}">
-                <a16:creationId xmlns:a16="http://schemas.microsoft.com/office/drawing/2014/main" id="{DFEC6709-BCAA-4388-B75D-4B6BB53AC2B0}"/>
+                <a16:creationId xmlns:a16="http://schemas.microsoft.com/office/drawing/2014/main" id="{D21FB2B3-41DC-4508-A3CF-8E84CD684D01}"/>
               </a:ext>
             </a:extLst>
           </p:cNvPr>
@@ -5338,7 +5343,7 @@
           <p:cNvPr id="5" name="close-action">
             <a:extLst xmlns:a="http://schemas.openxmlformats.org/drawingml/2006/main">
               <a:ext uri="{FF2B5EF4-FFF2-40B4-BE49-F238E27FC236}">
-                <a16:creationId xmlns:a16="http://schemas.microsoft.com/office/drawing/2014/main" id="{907DB5B7-975F-4BA9-89B9-146C4ABB77D4}"/>
+                <a16:creationId xmlns:a16="http://schemas.microsoft.com/office/drawing/2014/main" id="{7D55F3D4-B44B-48D9-B1DD-041ACB7AAF9E}"/>
               </a:ext>
             </a:extLst>
           </p:cNvPr>
@@ -5388,7 +5393,7 @@
           <p:cNvPr id="6" name="close-number">
             <a:extLst xmlns:a="http://schemas.openxmlformats.org/drawingml/2006/main">
               <a:ext uri="{FF2B5EF4-FFF2-40B4-BE49-F238E27FC236}">
-                <a16:creationId xmlns:a16="http://schemas.microsoft.com/office/drawing/2014/main" id="{7D69A720-4EC4-4961-983E-5C0384C7791E}"/>
+                <a16:creationId xmlns:a16="http://schemas.microsoft.com/office/drawing/2014/main" id="{08A7976E-47A8-4FAC-9C53-60C946CE3D27}"/>
               </a:ext>
             </a:extLst>
           </p:cNvPr>
@@ -5436,7 +5441,7 @@
     </p:spTree>
     <p:extLst>
       <p:ext uri="{BB962C8B-B14F-4D97-AF65-F5344CB8AC3E}">
-        <p14:creationId xmlns:p14="http://schemas.microsoft.com/office/powerpoint/2010/main" val="1857320922"/>
+        <p14:creationId xmlns:p14="http://schemas.microsoft.com/office/powerpoint/2010/main" val="1040592894"/>
       </p:ext>
     </p:extLst>
   </p:cSld>

</xml_diff>